<commit_message>
Update walkthrough deck with team name and Next.js frontend details
</commit_message>
<xml_diff>
--- a/docs/deck/chakravyuh-walkthrough.pptx
+++ b/docs/deck/chakravyuh-walkthrough.pptx
@@ -4751,7 +4751,7 @@
           </a:p>
           <a:p>
             <a:r>
-              <a:t>[Team name / members]</a:t>
+              <a:t>Team Chakravyuh (@Sharkyii)</a:t>
             </a:r>
           </a:p>
         </p:txBody>
@@ -6090,7 +6090,7 @@
               </a:defRPr>
             </a:pPr>
             <a:r>
-              <a:t>Streamlit app (web/app.py) -- uv run streamlit run web/app.py</a:t>
+              <a:t>Next.js frontend + FastAPI backend -- Analyst Portal UI (web/next-app, web/api.py)</a:t>
             </a:r>
           </a:p>
           <a:p>
@@ -6358,7 +6358,7 @@
               </a:defRPr>
             </a:pPr>
             <a:r>
-              <a:t>[Team contact]</a:t>
+              <a:t>Contact: github.com/Sharkyii</a:t>
             </a:r>
           </a:p>
         </p:txBody>

</xml_diff>